<commit_message>
Add bonus-point rule, two bonus findings and known AI mistakes
Answer key: +1 for valid unplanted findings, B1 (fixed menu prices erode
margin) and B2 (FX translation flatters Warsaw), plus mistakes from test runs.
Deck: bonus row on the scoring slide.

Co-Authored-By: Claude Opus 5.5 <noreply@anthropic.com>
Claude-Session: https://claude.ai/code/session_01AtTVZfAYhjK6stM5CABg1h
</commit_message>
<xml_diff>
--- a/facilitator/Frankly_Delicious_AI_Workshop.pptx
+++ b/facilitator/Frankly_Delicious_AI_Workshop.pptx
@@ -132,7 +132,7 @@
   <p:extLst>
     <p:ext uri="{521415D9-36F7-43E2-AB2F-B90AF26B5E84}">
       <p14:sectionLst xmlns:p14="http://schemas.microsoft.com/office/powerpoint/2010/main">
-        <p14:section name="Intro" id="{b9827b43-f3d8-329e-7927-fa150f5059cc}">
+        <p14:section name="Intro" id="{40beb17e-7a68-663f-e80f-57dfad4c1441}">
           <p14:sldIdLst>
             <p14:sldId id="256"/>
             <p14:sldId id="257"/>
@@ -140,7 +140,7 @@
             <p14:sldId id="259"/>
           </p14:sldIdLst>
         </p14:section>
-        <p14:section name="The data" id="{4ab64438-adfe-947e-d0be-2fa1d8fb9d02}">
+        <p14:section name="The data" id="{6ba5412f-1343-aa85-37b7-70d04899870a}">
           <p14:sldIdLst>
             <p14:sldId id="260"/>
             <p14:sldId id="261"/>
@@ -149,13 +149,13 @@
             <p14:sldId id="264"/>
           </p14:sldIdLst>
         </p14:section>
-        <p14:section name="No-AI round" id="{5983e79b-077e-81a0-af89-bbcaf89b73a7}">
+        <p14:section name="No-AI round" id="{bcf53639-b2a4-7d3d-4c84-68b1cceb0f22}">
           <p14:sldIdLst>
             <p14:sldId id="265"/>
             <p14:sldId id="266"/>
           </p14:sldIdLst>
         </p14:section>
-        <p14:section name="Your mission" id="{cf8d3eb0-deed-e40d-f016-a1f5b592584e}">
+        <p14:section name="Your mission" id="{bcf07ecc-1e3c-8c66-9632-7d3dbdc03c00}">
           <p14:sldIdLst>
             <p14:sldId id="267"/>
             <p14:sldId id="268"/>
@@ -163,7 +163,7 @@
             <p14:sldId id="270"/>
           </p14:sldIdLst>
         </p14:section>
-        <p14:section name="Reveal" id="{ddde2455-d2c0-f15d-b069-a7b448df8a35}">
+        <p14:section name="Reveal" id="{4e70ff72-c4f2-7f3e-88be-0ccff719c4ee}">
           <p14:sldIdLst>
             <p14:sldId id="271"/>
             <p14:sldId id="272"/>
@@ -2661,7 +2661,7 @@
           <a:p>
             <a:r>
               <a:rPr lang="en-US" dirty="0"/>
-              <a:t>There are several hidden stories in the data, from easy to hard, plus a couple of traps. We reveal everything at the end.</a:t>
+              <a:t>There are several hidden stories in the data, from easy to hard, plus a couple of traps. We reveal everything at the end. The answer key is not the ceiling: any true finding we did not plant earns a bonus point, as long as it is backed by numbers.</a:t>
             </a:r>
             <a:endParaRPr lang="en-US" dirty="0"/>
           </a:p>
@@ -8286,6 +8286,130 @@
                           </a:solidFill>
                         </a:rPr>
                         <a:t>−1</a:t>
+                      </a:r>
+                      <a:endParaRPr lang="en-US" sz="1400" dirty="0"/>
+                    </a:p>
+                  </a:txBody>
+                  <a:tcPr marL="91440" marR="91440" marT="45720" marB="45720" anchor="ctr">
+                    <a:lnL w="6350" cap="flat" cmpd="sng" algn="ctr">
+                      <a:solidFill>
+                        <a:srgbClr val="E6E1DA"/>
+                      </a:solidFill>
+                      <a:prstDash val="solid"/>
+                      <a:round/>
+                      <a:headEnd type="none" w="med" len="med"/>
+                      <a:tailEnd type="none" w="med" len="med"/>
+                    </a:lnL>
+                    <a:lnR w="6350" cap="flat" cmpd="sng" algn="ctr">
+                      <a:solidFill>
+                        <a:srgbClr val="E6E1DA"/>
+                      </a:solidFill>
+                      <a:prstDash val="solid"/>
+                      <a:round/>
+                      <a:headEnd type="none" w="med" len="med"/>
+                      <a:tailEnd type="none" w="med" len="med"/>
+                    </a:lnR>
+                    <a:lnT w="6350" cap="flat" cmpd="sng" algn="ctr">
+                      <a:solidFill>
+                        <a:srgbClr val="E6E1DA"/>
+                      </a:solidFill>
+                      <a:prstDash val="solid"/>
+                      <a:round/>
+                      <a:headEnd type="none" w="med" len="med"/>
+                      <a:tailEnd type="none" w="med" len="med"/>
+                    </a:lnT>
+                    <a:lnB w="6350" cap="flat" cmpd="sng" algn="ctr">
+                      <a:solidFill>
+                        <a:srgbClr val="E6E1DA"/>
+                      </a:solidFill>
+                      <a:prstDash val="solid"/>
+                      <a:round/>
+                      <a:headEnd type="none" w="med" len="med"/>
+                      <a:tailEnd type="none" w="med" len="med"/>
+                    </a:lnB>
+                    <a:solidFill>
+                      <a:srgbClr val="FFF3CC"/>
+                    </a:solidFill>
+                  </a:tcPr>
+                </a:tc>
+              </a:tr>
+              <a:tr h="438912">
+                <a:tc>
+                  <a:txBody>
+                    <a:bodyPr/>
+                    <a:lstStyle/>
+                    <a:p>
+                      <a:pPr indent="0" marL="0">
+                        <a:buNone/>
+                      </a:pPr>
+                      <a:r>
+                        <a:rPr lang="en-US" sz="1400" b="1" dirty="0">
+                          <a:solidFill>
+                            <a:schemeClr val="tx1"/>
+                          </a:solidFill>
+                        </a:rPr>
+                        <a:t>Bonus: a finding we didn't plant</a:t>
+                      </a:r>
+                      <a:endParaRPr lang="en-US" sz="1400" dirty="0"/>
+                    </a:p>
+                  </a:txBody>
+                  <a:tcPr marL="91440" marR="91440" marT="45720" marB="45720" anchor="ctr">
+                    <a:lnL w="6350" cap="flat" cmpd="sng" algn="ctr">
+                      <a:solidFill>
+                        <a:srgbClr val="E6E1DA"/>
+                      </a:solidFill>
+                      <a:prstDash val="solid"/>
+                      <a:round/>
+                      <a:headEnd type="none" w="med" len="med"/>
+                      <a:tailEnd type="none" w="med" len="med"/>
+                    </a:lnL>
+                    <a:lnR w="6350" cap="flat" cmpd="sng" algn="ctr">
+                      <a:solidFill>
+                        <a:srgbClr val="E6E1DA"/>
+                      </a:solidFill>
+                      <a:prstDash val="solid"/>
+                      <a:round/>
+                      <a:headEnd type="none" w="med" len="med"/>
+                      <a:tailEnd type="none" w="med" len="med"/>
+                    </a:lnR>
+                    <a:lnT w="6350" cap="flat" cmpd="sng" algn="ctr">
+                      <a:solidFill>
+                        <a:srgbClr val="E6E1DA"/>
+                      </a:solidFill>
+                      <a:prstDash val="solid"/>
+                      <a:round/>
+                      <a:headEnd type="none" w="med" len="med"/>
+                      <a:tailEnd type="none" w="med" len="med"/>
+                    </a:lnT>
+                    <a:lnB w="6350" cap="flat" cmpd="sng" algn="ctr">
+                      <a:solidFill>
+                        <a:srgbClr val="E6E1DA"/>
+                      </a:solidFill>
+                      <a:prstDash val="solid"/>
+                      <a:round/>
+                      <a:headEnd type="none" w="med" len="med"/>
+                      <a:tailEnd type="none" w="med" len="med"/>
+                    </a:lnB>
+                    <a:solidFill>
+                      <a:srgbClr val="FFF3CC"/>
+                    </a:solidFill>
+                  </a:tcPr>
+                </a:tc>
+                <a:tc>
+                  <a:txBody>
+                    <a:bodyPr/>
+                    <a:lstStyle/>
+                    <a:p>
+                      <a:pPr algn="ctr" indent="0" marL="0">
+                        <a:buNone/>
+                      </a:pPr>
+                      <a:r>
+                        <a:rPr lang="en-US" sz="1400" b="1" dirty="0">
+                          <a:solidFill>
+                            <a:schemeClr val="tx1"/>
+                          </a:solidFill>
+                        </a:rPr>
+                        <a:t>+1</a:t>
                       </a:r>
                       <a:endParaRPr lang="en-US" sz="1400" dirty="0"/>
                     </a:p>

</xml_diff>